<commit_message>
docs(slides): populate Week 11 presentation slide deck
</commit_message>
<xml_diff>
--- a/docs/slides/presentation/Week 11 Slide Template.pptx
+++ b/docs/slides/presentation/Week 11 Slide Template.pptx
@@ -4069,17 +4069,18 @@
           </a:lstStyle>
           <a:p>
             <a:pPr>
-              <a:defRPr/>
+              <a:defRPr sz="2800" b="1"/>
             </a:pPr>
             <a:r>
-              <a:rPr lang="en-US" altLang="en-US" b="1">
-                <a:solidFill>
-                  <a:schemeClr val="accent4">
-                    <a:lumMod val="75000"/>
-                  </a:schemeClr>
-                </a:solidFill>
-              </a:rPr>
-              <a:t>IS212 Project Slide Template</a:t>
+              <a:t>ConnectSphere — IS212 Project Presentation</a:t>
+            </a:r>
+          </a:p>
+          <a:p>
+            <a:pPr>
+              <a:defRPr sz="2800" b="1"/>
+            </a:pPr>
+            <a:r>
+              <a:t>AY2026/27 Team: ConnectSphere</a:t>
             </a:r>
           </a:p>
         </p:txBody>
@@ -4290,6 +4291,7 @@
                     <a:p>
                       <a:pPr>
                         <a:buNone/>
+                        <a:defRPr sz="1000"/>
                       </a:pPr>
                       <a:r>
                         <a:rPr lang="en-SG" b="1"/>
@@ -4306,6 +4308,7 @@
                     <a:p>
                       <a:pPr algn="r">
                         <a:buNone/>
+                        <a:defRPr sz="1000"/>
                       </a:pPr>
                       <a:r>
                         <a:rPr lang="en-SG" b="1"/>
@@ -4329,6 +4332,7 @@
                     <a:p>
                       <a:pPr>
                         <a:buNone/>
+                        <a:defRPr sz="1000"/>
                       </a:pPr>
                       <a:r>
                         <a:rPr lang="en-SG"/>
@@ -4343,10 +4347,12 @@
                     <a:bodyPr/>
                     <a:lstStyle/>
                     <a:p>
-                      <a:pPr algn="r">
-                        <a:buNone/>
+                      <a:pPr>
+                        <a:defRPr sz="1000"/>
                       </a:pPr>
-                      <a:endParaRPr lang="en-SG"/>
+                      <a:r>
+                        <a:t>64 test cases documented in docs/testing/cases/ and PROJECT TEST CASES CAA.xlsx</a:t>
+                      </a:r>
                     </a:p>
                   </a:txBody>
                   <a:tcPr anchor="ctr"/>
@@ -4365,6 +4371,7 @@
                     <a:p>
                       <a:pPr>
                         <a:buNone/>
+                        <a:defRPr sz="1000"/>
                       </a:pPr>
                       <a:r>
                         <a:rPr lang="en-SG"/>
@@ -4379,10 +4386,12 @@
                     <a:bodyPr/>
                     <a:lstStyle/>
                     <a:p>
-                      <a:pPr algn="r">
-                        <a:buNone/>
+                      <a:pPr>
+                        <a:defRPr sz="1000"/>
                       </a:pPr>
-                      <a:endParaRPr lang="en-SG"/>
+                      <a:r>
+                        <a:t>799 unit tests (671 frontend Vitest + 128 backend unit tests)</a:t>
+                      </a:r>
                     </a:p>
                   </a:txBody>
                   <a:tcPr anchor="ctr"/>
@@ -4401,6 +4410,7 @@
                     <a:p>
                       <a:pPr>
                         <a:buNone/>
+                        <a:defRPr sz="1000"/>
                       </a:pPr>
                       <a:r>
                         <a:rPr lang="en-SG"/>
@@ -4415,10 +4425,12 @@
                     <a:bodyPr/>
                     <a:lstStyle/>
                     <a:p>
-                      <a:pPr algn="r">
-                        <a:buNone/>
+                      <a:pPr>
+                        <a:defRPr sz="1000"/>
                       </a:pPr>
-                      <a:endParaRPr lang="en-SG"/>
+                      <a:r>
+                        <a:t>42 integration tests (backend database rollback &amp; API suites)</a:t>
+                      </a:r>
                     </a:p>
                   </a:txBody>
                   <a:tcPr anchor="ctr"/>
@@ -4437,6 +4449,7 @@
                     <a:p>
                       <a:pPr>
                         <a:buNone/>
+                        <a:defRPr sz="1000"/>
                       </a:pPr>
                       <a:r>
                         <a:rPr lang="en-SG"/>
@@ -4451,10 +4464,12 @@
                     <a:bodyPr/>
                     <a:lstStyle/>
                     <a:p>
-                      <a:pPr algn="r">
-                        <a:buNone/>
+                      <a:pPr>
+                        <a:defRPr sz="1000"/>
                       </a:pPr>
-                      <a:endParaRPr lang="en-SG"/>
+                      <a:r>
+                        <a:t>28 Playwright browser E2E specs (covering E01 to E14)</a:t>
+                      </a:r>
                     </a:p>
                   </a:txBody>
                   <a:tcPr anchor="ctr"/>
@@ -4473,6 +4488,7 @@
                     <a:p>
                       <a:pPr>
                         <a:buNone/>
+                        <a:defRPr sz="1000"/>
                       </a:pPr>
                       <a:r>
                         <a:rPr lang="en-SG"/>
@@ -4487,10 +4503,12 @@
                     <a:bodyPr/>
                     <a:lstStyle/>
                     <a:p>
-                      <a:pPr algn="r">
-                        <a:buNone/>
+                      <a:pPr>
+                        <a:defRPr sz="1000"/>
                       </a:pPr>
-                      <a:endParaRPr lang="en-SG"/>
+                      <a:r>
+                        <a:t>100% unit test coverage on changed code (strictly enforced by CI gate)</a:t>
+                      </a:r>
                     </a:p>
                   </a:txBody>
                   <a:tcPr anchor="ctr"/>
@@ -4509,6 +4527,7 @@
                     <a:p>
                       <a:pPr>
                         <a:buNone/>
+                        <a:defRPr sz="1000"/>
                       </a:pPr>
                       <a:r>
                         <a:rPr lang="en-SG"/>
@@ -4523,10 +4542,12 @@
                     <a:bodyPr/>
                     <a:lstStyle/>
                     <a:p>
-                      <a:pPr algn="r">
-                        <a:buNone/>
+                      <a:pPr>
+                        <a:defRPr sz="1000"/>
                       </a:pPr>
-                      <a:endParaRPr lang="en-SG"/>
+                      <a:r>
+                        <a:t>All test suites passing (869 automated tests green)</a:t>
+                      </a:r>
                     </a:p>
                   </a:txBody>
                   <a:tcPr anchor="ctr"/>
@@ -4545,6 +4566,7 @@
                     <a:p>
                       <a:pPr>
                         <a:buNone/>
+                        <a:defRPr sz="1000"/>
                       </a:pPr>
                       <a:r>
                         <a:rPr lang="en-SG"/>
@@ -4559,10 +4581,12 @@
                     <a:bodyPr/>
                     <a:lstStyle/>
                     <a:p>
-                      <a:pPr algn="r">
-                        <a:buNone/>
+                      <a:pPr>
+                        <a:defRPr sz="1000"/>
                       </a:pPr>
-                      <a:endParaRPr lang="en-SG"/>
+                      <a:r>
+                        <a:t>0 failing tests</a:t>
+                      </a:r>
                     </a:p>
                   </a:txBody>
                   <a:tcPr anchor="ctr"/>
@@ -4581,6 +4605,7 @@
                     <a:p>
                       <a:pPr>
                         <a:buNone/>
+                        <a:defRPr sz="1000"/>
                       </a:pPr>
                       <a:r>
                         <a:rPr lang="en-SG"/>
@@ -4595,12 +4620,11 @@
                     <a:bodyPr/>
                     <a:lstStyle/>
                     <a:p>
-                      <a:pPr algn="r">
-                        <a:buNone/>
+                      <a:pPr>
+                        <a:defRPr sz="1000"/>
                       </a:pPr>
                       <a:r>
-                        <a:rPr lang="en-SG"/>
-                        <a:t>Pass/Fail</a:t>
+                        <a:t>Pass (16/16 CI checks green on main)</a:t>
                       </a:r>
                     </a:p>
                   </a:txBody>
@@ -4620,6 +4644,7 @@
                     <a:p>
                       <a:pPr>
                         <a:buNone/>
+                        <a:defRPr sz="1000"/>
                       </a:pPr>
                       <a:r>
                         <a:rPr lang="en-SG"/>
@@ -4634,10 +4659,12 @@
                     <a:bodyPr/>
                     <a:lstStyle/>
                     <a:p>
-                      <a:pPr algn="r">
-                        <a:buNone/>
+                      <a:pPr>
+                        <a:defRPr sz="1000"/>
                       </a:pPr>
-                      <a:endParaRPr lang="en-SG"/>
+                      <a:r>
+                        <a:t>0 known unresolved defects</a:t>
+                      </a:r>
                     </a:p>
                   </a:txBody>
                   <a:tcPr anchor="ctr"/>
@@ -4685,9 +4712,16 @@
           </a:bodyPr>
           <a:lstStyle/>
           <a:p>
-            <a:r>
-              <a:rPr lang="en-US" i="1"/>
-              <a:t>Type answer here…</a:t>
+            <a:pPr>
+              <a:defRPr sz="1200"/>
+            </a:pPr>
+            <a:r>
+              <a:t>Overly-isolated Mock-Only Unit Tests:</a:t>
+            </a:r>
+          </a:p>
+          <a:p>
+            <a:r>
+              <a:t>Unit tests that heavily mocked the database layer and external browser events provided the least practical value. They often passed even when underlying SQL column types mismatched or when DOM focus transitions failed in real browsers. Value dramatically increased when we shifted towards integration tests with rollback transactions and Playwright browser tests.</a:t>
             </a:r>
           </a:p>
         </p:txBody>
@@ -4922,19 +4956,12 @@
           </a:bodyPr>
           <a:lstStyle/>
           <a:p>
-            <a:r>
-              <a:rPr lang="en-US" i="1"/>
-              <a:t>Type answer here…</a:t>
-            </a:r>
-          </a:p>
-          <a:p>
-            <a:endParaRPr lang="en-US"/>
-          </a:p>
-          <a:p>
-            <a:endParaRPr lang="en-US"/>
-          </a:p>
-          <a:p>
-            <a:endParaRPr lang="en-US"/>
+            <a:pPr>
+              <a:defRPr sz="1200"/>
+            </a:pPr>
+            <a:r>
+              <a:t>Identified edge cases through boundary analysis and state-transition modelling: concurrent booking submissions within the same millisecond, negative capacities, venue unavailability spanning across existing multi-day reservations, registration cancellations when waiting lists are empty vs populated, and rapid double-click form submissions.</a:t>
+            </a:r>
           </a:p>
         </p:txBody>
       </p:sp>
@@ -5010,19 +5037,12 @@
           </a:bodyPr>
           <a:lstStyle/>
           <a:p>
-            <a:r>
-              <a:rPr lang="en-US" i="1"/>
-              <a:t>Type answer here…</a:t>
-            </a:r>
-          </a:p>
-          <a:p>
-            <a:endParaRPr lang="en-US"/>
-          </a:p>
-          <a:p>
-            <a:endParaRPr lang="en-US"/>
-          </a:p>
-          <a:p>
-            <a:endParaRPr lang="en-US"/>
+            <a:pPr>
+              <a:defRPr sz="1200"/>
+            </a:pPr>
+            <a:r>
+              <a:t>Customer changes introduced asynchronous state dependencies (e.g. waiting list promotions and turnaround buffer overlaps) that required testing time-based workflows and multi-role interactions (Organiser, Venue Staff, Coordinator, Attendee). CFO guidance reinforced our focus on cost efficiency, preventing expensive database resets and keeping CI execution lean.</a:t>
+            </a:r>
           </a:p>
         </p:txBody>
       </p:sp>
@@ -5098,19 +5118,22 @@
           </a:bodyPr>
           <a:lstStyle/>
           <a:p>
-            <a:r>
-              <a:rPr lang="en-US" i="1"/>
-              <a:t>Type answer here…</a:t>
-            </a:r>
-          </a:p>
-          <a:p>
-            <a:endParaRPr lang="en-US"/>
-          </a:p>
-          <a:p>
-            <a:endParaRPr lang="en-US"/>
-          </a:p>
-          <a:p>
-            <a:endParaRPr lang="en-US"/>
+            <a:pPr>
+              <a:defRPr sz="1100"/>
+            </a:pPr>
+            <a:r>
+              <a:t>Yes. In accordance with Team Decisions T-65 and T-93, every user story underwent mandatory manual click-through verification by team members before being accepted as Done.</a:t>
+            </a:r>
+          </a:p>
+          <a:p>
+            <a:r>
+              <a:t>• Process: Testers followed documented markdown scripts (docs/testing/manual/), set up preconditions via SQL scripts, executed flows in the browser, captured hand-taken screenshots, and committed session records to docs/testing/runs/.</a:t>
+            </a:r>
+          </a:p>
+          <a:p>
+            <a:r>
+              <a:t>• Challenges: Synchronising test accounts across roles without overwriting active test state required careful SQL fixture design.</a:t>
+            </a:r>
           </a:p>
         </p:txBody>
       </p:sp>
@@ -5330,6 +5353,7 @@
                     <a:p>
                       <a:pPr>
                         <a:buNone/>
+                        <a:defRPr sz="1000"/>
                       </a:pPr>
                       <a:r>
                         <a:rPr lang="en-SG" sz="1700" b="1"/>
@@ -5346,6 +5370,7 @@
                     <a:p>
                       <a:pPr>
                         <a:buNone/>
+                        <a:defRPr sz="1000"/>
                       </a:pPr>
                       <a:r>
                         <a:rPr lang="en-SG" sz="1700" b="1"/>
@@ -5369,6 +5394,7 @@
                     <a:p>
                       <a:pPr>
                         <a:buNone/>
+                        <a:defRPr sz="1000"/>
                       </a:pPr>
                       <a:r>
                         <a:rPr lang="en-SG" sz="1700"/>
@@ -5384,9 +5410,11 @@
                     <a:lstStyle/>
                     <a:p>
                       <a:pPr>
-                        <a:buNone/>
+                        <a:defRPr sz="1000"/>
                       </a:pPr>
-                      <a:endParaRPr lang="en-SG" sz="1700"/>
+                      <a:r>
+                        <a:t>Pull request open/synchronize/reopen, push to main, and manual workflow dispatch.</a:t>
+                      </a:r>
                     </a:p>
                   </a:txBody>
                   <a:tcPr marL="85320" marR="85320" marT="42660" marB="42660" anchor="ctr"/>
@@ -5405,6 +5433,7 @@
                     <a:p>
                       <a:pPr>
                         <a:buNone/>
+                        <a:defRPr sz="1000"/>
                       </a:pPr>
                       <a:r>
                         <a:rPr lang="en-SG" sz="1700"/>
@@ -5420,9 +5449,11 @@
                     <a:lstStyle/>
                     <a:p>
                       <a:pPr>
-                        <a:buNone/>
+                        <a:defRPr sz="1000"/>
                       </a:pPr>
-                      <a:endParaRPr lang="en-SG" sz="1700"/>
+                      <a:r>
+                        <a:t>pr-conventions, pr-guardrails (max 2 PRs/author), application-checks (lint, typecheck, Vitest, backend unit/db, Playwright E2E, check.py, tc-coverage audit).</a:t>
+                      </a:r>
                     </a:p>
                   </a:txBody>
                   <a:tcPr marL="85320" marR="85320" marT="42660" marB="42660" anchor="ctr"/>
@@ -5441,6 +5472,7 @@
                     <a:p>
                       <a:pPr>
                         <a:buNone/>
+                        <a:defRPr sz="1000"/>
                       </a:pPr>
                       <a:r>
                         <a:rPr lang="en-SG" sz="1700"/>
@@ -5456,9 +5488,11 @@
                     <a:lstStyle/>
                     <a:p>
                       <a:pPr>
-                        <a:buNone/>
+                        <a:defRPr sz="1000"/>
                       </a:pPr>
-                      <a:endParaRPr lang="en-SG" sz="1700"/>
+                      <a:r>
+                        <a:t>Yes. Enforced via GitHub branch protection rules requiring all status checks to be green.</a:t>
+                      </a:r>
                     </a:p>
                   </a:txBody>
                   <a:tcPr marL="85320" marR="85320" marT="42660" marB="42660" anchor="ctr"/>
@@ -5477,6 +5511,7 @@
                     <a:p>
                       <a:pPr>
                         <a:buNone/>
+                        <a:defRPr sz="1000"/>
                       </a:pPr>
                       <a:r>
                         <a:rPr lang="en-SG" sz="1700"/>
@@ -5493,9 +5528,11 @@
                     <a:lstStyle/>
                     <a:p>
                       <a:pPr>
-                        <a:buNone/>
+                        <a:defRPr sz="1000"/>
                       </a:pPr>
-                      <a:endParaRPr lang="en-SG" sz="1700"/>
+                      <a:r>
+                        <a:t>Approximately 38 CI failures across the 4 sprints (all caught pre-merge).</a:t>
+                      </a:r>
                     </a:p>
                   </a:txBody>
                   <a:tcPr marL="85320" marR="85320" marT="42660" marB="42660" anchor="ctr"/>
@@ -5514,6 +5551,7 @@
                     <a:p>
                       <a:pPr>
                         <a:buNone/>
+                        <a:defRPr sz="1000"/>
                       </a:pPr>
                       <a:r>
                         <a:rPr lang="en-SG" sz="1700"/>
@@ -5529,9 +5567,11 @@
                     <a:lstStyle/>
                     <a:p>
                       <a:pPr>
-                        <a:buNone/>
+                        <a:defRPr sz="1000"/>
                       </a:pPr>
-                      <a:endParaRPr lang="en-SG" sz="1700"/>
+                      <a:r>
+                        <a:t>The RefusedEdit navigation focus assertion race condition (#372) and author PR guardrail limit detection (#373).</a:t>
+                      </a:r>
                     </a:p>
                   </a:txBody>
                   <a:tcPr marL="85320" marR="85320" marT="42660" marB="42660" anchor="ctr"/>
@@ -5550,6 +5590,7 @@
                     <a:p>
                       <a:pPr>
                         <a:buNone/>
+                        <a:defRPr sz="1000"/>
                       </a:pPr>
                       <a:r>
                         <a:rPr lang="en-SG" sz="1700"/>
@@ -5565,9 +5606,11 @@
                     <a:lstStyle/>
                     <a:p>
                       <a:pPr>
-                        <a:buNone/>
+                        <a:defRPr sz="1000"/>
                       </a:pPr>
-                      <a:endParaRPr lang="en-SG" sz="1700"/>
+                      <a:r>
+                        <a:t>Caused by synchronous focus expectation before DOM rendering completed. Resolved by introducing web-first waitFor polling on container element in PR #373.</a:t>
+                      </a:r>
                     </a:p>
                   </a:txBody>
                   <a:tcPr marL="85320" marR="85320" marT="42660" marB="42660" anchor="ctr"/>
@@ -5586,6 +5629,7 @@
                     <a:p>
                       <a:pPr>
                         <a:buNone/>
+                        <a:defRPr sz="1000"/>
                       </a:pPr>
                       <a:r>
                         <a:rPr lang="en-SG" sz="1700"/>
@@ -5601,9 +5645,11 @@
                     <a:lstStyle/>
                     <a:p>
                       <a:pPr>
-                        <a:buNone/>
+                        <a:defRPr sz="1000"/>
                       </a:pPr>
-                      <a:endParaRPr lang="en-SG" sz="1700"/>
+                      <a:r>
+                        <a:t>Yes. An agent submitted a PR touching .agents/STATE.md directly. CI pr-conventions immediately blocked the merge, preventing severe branch conflict across teammate PRs.</a:t>
+                      </a:r>
                     </a:p>
                   </a:txBody>
                   <a:tcPr marL="85320" marR="85320" marT="42660" marB="42660" anchor="ctr"/>
@@ -5622,6 +5668,7 @@
                     <a:p>
                       <a:pPr>
                         <a:buNone/>
+                        <a:defRPr sz="1000"/>
                       </a:pPr>
                       <a:r>
                         <a:rPr lang="en-SG" sz="1700"/>
@@ -5637,9 +5684,11 @@
                     <a:lstStyle/>
                     <a:p>
                       <a:pPr>
-                        <a:buNone/>
+                        <a:defRPr sz="1000"/>
                       </a:pPr>
-                      <a:endParaRPr lang="en-SG" sz="1700"/>
+                      <a:r>
+                        <a:t>Never bypassed CI. Branch protection rules strictly prohibited force pushes or administrative bypasses. All issues were resolved through proper fix commits.</a:t>
+                      </a:r>
                     </a:p>
                   </a:txBody>
                   <a:tcPr marL="85320" marR="85320" marT="42660" marB="42660" anchor="ctr"/>
@@ -5826,19 +5875,27 @@
           </a:bodyPr>
           <a:lstStyle/>
           <a:p>
-            <a:r>
-              <a:rPr lang="en-US" i="1"/>
-              <a:t>Type answer here…</a:t>
-            </a:r>
-          </a:p>
-          <a:p>
-            <a:endParaRPr lang="en-US"/>
-          </a:p>
-          <a:p>
-            <a:endParaRPr lang="en-US"/>
-          </a:p>
-          <a:p>
-            <a:endParaRPr lang="en-US"/>
+            <a:pPr>
+              <a:defRPr sz="1200"/>
+            </a:pPr>
+            <a:r>
+              <a:t>1. Derived-Document Drift Audits: CI runs python scripts/check.py and scripts/tc_coverage_audit.py, automatically validating that .env.template and tc-coverage.md never drift from actual codebase usage. Any discrepancy fails the build.</a:t>
+            </a:r>
+          </a:p>
+          <a:p>
+            <a:r>
+              <a:t>2. Continuity &amp; State Protection Gate: Custom pre-commit and CI hooks prevent feature branches from editing shared continuity logs (STATE.md, JOURNAL.md), eliminating merge conflicts across parallel developer agents.</a:t>
+            </a:r>
+          </a:p>
+          <a:p>
+            <a:r>
+              <a:t>3. Worktree &amp; Artifact Hygiene: Automated scanners warn developers of orphaned worktrees or unstaged test evidence, keeping local workspaces pristine and preventing accidental credential leakage.</a:t>
+            </a:r>
+          </a:p>
+          <a:p>
+            <a:r>
+              <a:t>Benefit: Absolute reproducibility, zero merge lockouts, and 100% auditable traceability.</a:t>
+            </a:r>
           </a:p>
         </p:txBody>
       </p:sp>
@@ -6041,13 +6098,12 @@
           </a:bodyPr>
           <a:lstStyle/>
           <a:p>
-            <a:r>
-              <a:rPr lang="en-US" i="1"/>
-              <a:t>Type answer here…</a:t>
-            </a:r>
-          </a:p>
-          <a:p>
-            <a:endParaRPr lang="en-US"/>
+            <a:pPr>
+              <a:defRPr sz="1200"/>
+            </a:pPr>
+            <a:r>
+              <a:t>PR #373: Fix flaky focus assertion on RefusedEdit.navigation.test.tsx (E10-S01 / Issue #372).</a:t>
+            </a:r>
           </a:p>
         </p:txBody>
       </p:sp>
@@ -6131,13 +6187,12 @@
           </a:bodyPr>
           <a:lstStyle/>
           <a:p>
-            <a:r>
-              <a:rPr lang="en-US" i="1"/>
-              <a:t>Type answer here…</a:t>
-            </a:r>
-          </a:p>
-          <a:p>
-            <a:endParaRPr lang="en-US"/>
+            <a:pPr>
+              <a:defRPr sz="1200"/>
+            </a:pPr>
+            <a:r>
+              <a:t>pr-guardrails check failed with error: 'Author bryanseah234 has 3 open PRs (limit is 2: #370, #371, #373)'.</a:t>
+            </a:r>
           </a:p>
         </p:txBody>
       </p:sp>
@@ -6221,13 +6276,12 @@
           </a:bodyPr>
           <a:lstStyle/>
           <a:p>
-            <a:r>
-              <a:rPr lang="en-US" i="1"/>
-              <a:t>Type answer here…</a:t>
-            </a:r>
-          </a:p>
-          <a:p>
-            <a:endParaRPr lang="en-US"/>
+            <a:pPr>
+              <a:defRPr sz="1200"/>
+            </a:pPr>
+            <a:r>
+              <a:t>The automated guardrail prevented WIP overload and author bottlenecking. It ensured that developer attention was focused on reviewing and merging pending in-flight PRs (#370, #371) before introducing additional work into the pipeline.</a:t>
+            </a:r>
           </a:p>
         </p:txBody>
       </p:sp>
@@ -6311,13 +6365,12 @@
           </a:bodyPr>
           <a:lstStyle/>
           <a:p>
-            <a:r>
-              <a:rPr lang="en-US" i="1"/>
-              <a:t>Type answer here…</a:t>
-            </a:r>
-          </a:p>
-          <a:p>
-            <a:endParaRPr lang="en-US"/>
+            <a:pPr>
+              <a:defRPr sz="1200"/>
+            </a:pPr>
+            <a:r>
+              <a:t>Reconciled and reviewed upstream dependencies, merged PR #368 and ready review items, unblocking the author's queue so PR #373 could cleanly merge with green CI across all 16 checks.</a:t>
+            </a:r>
           </a:p>
         </p:txBody>
       </p:sp>
@@ -6531,6 +6584,7 @@
                     <a:p>
                       <a:pPr>
                         <a:buNone/>
+                        <a:defRPr sz="1000"/>
                       </a:pPr>
                       <a:r>
                         <a:rPr lang="en-SG" b="1"/>
@@ -6547,6 +6601,7 @@
                     <a:p>
                       <a:pPr>
                         <a:buNone/>
+                        <a:defRPr sz="1000"/>
                       </a:pPr>
                       <a:r>
                         <a:rPr lang="en-SG" b="1"/>
@@ -6563,6 +6618,7 @@
                     <a:p>
                       <a:pPr>
                         <a:buNone/>
+                        <a:defRPr sz="1000"/>
                       </a:pPr>
                       <a:r>
                         <a:rPr lang="en-SG" b="1"/>
@@ -6579,6 +6635,7 @@
                     <a:p>
                       <a:pPr>
                         <a:buNone/>
+                        <a:defRPr sz="1000"/>
                       </a:pPr>
                       <a:r>
                         <a:rPr lang="en-SG" b="1"/>
@@ -6595,6 +6652,7 @@
                     <a:p>
                       <a:pPr>
                         <a:buNone/>
+                        <a:defRPr sz="1000"/>
                       </a:pPr>
                       <a:r>
                         <a:rPr lang="en-SG" b="1"/>
@@ -6617,9 +6675,11 @@
                     <a:lstStyle/>
                     <a:p>
                       <a:pPr>
-                        <a:buNone/>
+                        <a:defRPr sz="1000"/>
                       </a:pPr>
-                      <a:endParaRPr lang="en-SG"/>
+                      <a:r>
+                        <a:t>Bryan Seah (bryanseah234)</a:t>
+                      </a:r>
                     </a:p>
                   </a:txBody>
                   <a:tcPr anchor="ctr"/>
@@ -6630,9 +6690,11 @@
                     <a:lstStyle/>
                     <a:p>
                       <a:pPr>
-                        <a:buNone/>
+                        <a:defRPr sz="1000"/>
                       </a:pPr>
-                      <a:endParaRPr lang="en-SG"/>
+                      <a:r>
+                        <a:t>CI/CD Pipeline, Tooling, Git Strategy, PostPlan, Architecture, Fixes</a:t>
+                      </a:r>
                     </a:p>
                   </a:txBody>
                   <a:tcPr anchor="ctr"/>
@@ -6643,9 +6705,11 @@
                     <a:lstStyle/>
                     <a:p>
                       <a:pPr>
-                        <a:buNone/>
+                        <a:defRPr sz="1000"/>
                       </a:pPr>
-                      <a:endParaRPr lang="en-SG"/>
+                      <a:r>
+                        <a:t>20%</a:t>
+                      </a:r>
                     </a:p>
                   </a:txBody>
                   <a:tcPr anchor="ctr"/>
@@ -6656,9 +6720,11 @@
                     <a:lstStyle/>
                     <a:p>
                       <a:pPr>
-                        <a:buNone/>
+                        <a:defRPr sz="1000"/>
                       </a:pPr>
-                      <a:endParaRPr lang="en-SG"/>
+                      <a:r>
+                        <a:t>PR #370, #371, #373, #374</a:t>
+                      </a:r>
                     </a:p>
                   </a:txBody>
                   <a:tcPr anchor="ctr"/>
@@ -6669,9 +6735,11 @@
                     <a:lstStyle/>
                     <a:p>
                       <a:pPr>
-                        <a:buNone/>
+                        <a:defRPr sz="1000"/>
                       </a:pPr>
-                      <a:endParaRPr lang="en-SG"/>
+                      <a:r>
+                        <a:t>PostPlan burndown dashboards, Jira reconciliation, .env generator</a:t>
+                      </a:r>
                     </a:p>
                   </a:txBody>
                   <a:tcPr anchor="ctr"/>
@@ -6689,9 +6757,11 @@
                     <a:lstStyle/>
                     <a:p>
                       <a:pPr>
-                        <a:buNone/>
+                        <a:defRPr sz="1000"/>
                       </a:pPr>
-                      <a:endParaRPr lang="en-SG"/>
+                      <a:r>
+                        <a:t>Ji Ning (jininggg)</a:t>
+                      </a:r>
                     </a:p>
                   </a:txBody>
                   <a:tcPr anchor="ctr"/>
@@ -6702,9 +6772,11 @@
                     <a:lstStyle/>
                     <a:p>
                       <a:pPr>
-                        <a:buNone/>
+                        <a:defRPr sz="1000"/>
                       </a:pPr>
-                      <a:endParaRPr lang="en-SG"/>
+                      <a:r>
+                        <a:t>Venue Management, Booking Workflows, Near-Match Scoring, Advisory</a:t>
+                      </a:r>
                     </a:p>
                   </a:txBody>
                   <a:tcPr anchor="ctr"/>
@@ -6715,9 +6787,11 @@
                     <a:lstStyle/>
                     <a:p>
                       <a:pPr>
-                        <a:buNone/>
+                        <a:defRPr sz="1000"/>
                       </a:pPr>
-                      <a:endParaRPr lang="en-SG"/>
+                      <a:r>
+                        <a:t>20%</a:t>
+                      </a:r>
                     </a:p>
                   </a:txBody>
                   <a:tcPr anchor="ctr"/>
@@ -6728,9 +6802,11 @@
                     <a:lstStyle/>
                     <a:p>
                       <a:pPr>
-                        <a:buNone/>
+                        <a:defRPr sz="1000"/>
                       </a:pPr>
-                      <a:endParaRPr lang="en-SG"/>
+                      <a:r>
+                        <a:t>PR #242, #300, #299, #108</a:t>
+                      </a:r>
                     </a:p>
                   </a:txBody>
                   <a:tcPr anchor="ctr"/>
@@ -6741,9 +6817,11 @@
                     <a:lstStyle/>
                     <a:p>
                       <a:pPr>
-                        <a:buNone/>
+                        <a:defRPr sz="1000"/>
                       </a:pPr>
-                      <a:endParaRPr lang="en-SG"/>
+                      <a:r>
+                        <a:t>Team Decision T-63 (Near-Match Scoring), manual test runs</a:t>
+                      </a:r>
                     </a:p>
                   </a:txBody>
                   <a:tcPr anchor="ctr"/>
@@ -6761,9 +6839,11 @@
                     <a:lstStyle/>
                     <a:p>
                       <a:pPr>
-                        <a:buNone/>
+                        <a:defRPr sz="1000"/>
                       </a:pPr>
-                      <a:endParaRPr lang="en-SG"/>
+                      <a:r>
+                        <a:t>Aaron Koh (aaronkwk / Bl0oper)</a:t>
+                      </a:r>
                     </a:p>
                   </a:txBody>
                   <a:tcPr anchor="ctr"/>
@@ -6774,9 +6854,11 @@
                     <a:lstStyle/>
                     <a:p>
                       <a:pPr>
-                        <a:buNone/>
+                        <a:defRPr sz="1000"/>
                       </a:pPr>
-                      <a:endParaRPr lang="en-SG"/>
+                      <a:r>
+                        <a:t>Auth, User Profiles, Role Scopes, Navigation &amp; App Shell</a:t>
+                      </a:r>
                     </a:p>
                   </a:txBody>
                   <a:tcPr anchor="ctr"/>
@@ -6787,9 +6869,11 @@
                     <a:lstStyle/>
                     <a:p>
                       <a:pPr>
-                        <a:buNone/>
+                        <a:defRPr sz="1000"/>
                       </a:pPr>
-                      <a:endParaRPr lang="en-SG"/>
+                      <a:r>
+                        <a:t>20%</a:t>
+                      </a:r>
                     </a:p>
                   </a:txBody>
                   <a:tcPr anchor="ctr"/>
@@ -6800,9 +6884,11 @@
                     <a:lstStyle/>
                     <a:p>
                       <a:pPr>
-                        <a:buNone/>
+                        <a:defRPr sz="1000"/>
                       </a:pPr>
-                      <a:endParaRPr lang="en-SG"/>
+                      <a:r>
+                        <a:t>PR #88, #96, #143</a:t>
+                      </a:r>
                     </a:p>
                   </a:txBody>
                   <a:tcPr anchor="ctr"/>
@@ -6813,9 +6899,11 @@
                     <a:lstStyle/>
                     <a:p>
                       <a:pPr>
-                        <a:buNone/>
+                        <a:defRPr sz="1000"/>
                       </a:pPr>
-                      <a:endParaRPr lang="en-SG"/>
+                      <a:r>
+                        <a:t>Test accounts mapping, role-based access control policies</a:t>
+                      </a:r>
                     </a:p>
                   </a:txBody>
                   <a:tcPr anchor="ctr"/>
@@ -6833,9 +6921,11 @@
                     <a:lstStyle/>
                     <a:p>
                       <a:pPr>
-                        <a:buNone/>
+                        <a:defRPr sz="1000"/>
                       </a:pPr>
-                      <a:endParaRPr lang="en-SG"/>
+                      <a:r>
+                        <a:t>Lexin Phun (lexinphun2024)</a:t>
+                      </a:r>
                     </a:p>
                   </a:txBody>
                   <a:tcPr anchor="ctr"/>
@@ -6846,9 +6936,11 @@
                     <a:lstStyle/>
                     <a:p>
                       <a:pPr>
-                        <a:buNone/>
+                        <a:defRPr sz="1000"/>
                       </a:pPr>
-                      <a:endParaRPr lang="en-SG"/>
+                      <a:r>
+                        <a:t>Venue Unavailability, Booking Hold Expiry, Concurrency, Recovery</a:t>
+                      </a:r>
                     </a:p>
                   </a:txBody>
                   <a:tcPr anchor="ctr"/>
@@ -6859,9 +6951,11 @@
                     <a:lstStyle/>
                     <a:p>
                       <a:pPr>
-                        <a:buNone/>
+                        <a:defRPr sz="1000"/>
                       </a:pPr>
-                      <a:endParaRPr lang="en-SG"/>
+                      <a:r>
+                        <a:t>20%</a:t>
+                      </a:r>
                     </a:p>
                   </a:txBody>
                   <a:tcPr anchor="ctr"/>
@@ -6872,9 +6966,11 @@
                     <a:lstStyle/>
                     <a:p>
                       <a:pPr>
-                        <a:buNone/>
+                        <a:defRPr sz="1000"/>
                       </a:pPr>
-                      <a:endParaRPr lang="en-SG"/>
+                      <a:r>
+                        <a:t>PR #348, #349, #367</a:t>
+                      </a:r>
                     </a:p>
                   </a:txBody>
                   <a:tcPr anchor="ctr"/>
@@ -6885,9 +6981,11 @@
                     <a:lstStyle/>
                     <a:p>
                       <a:pPr>
-                        <a:buNone/>
+                        <a:defRPr sz="1000"/>
                       </a:pPr>
-                      <a:endParaRPr lang="en-SG"/>
+                      <a:r>
+                        <a:t>DB migration 0025, extensive manual test runs &amp; screenshots</a:t>
+                      </a:r>
                     </a:p>
                   </a:txBody>
                   <a:tcPr anchor="ctr"/>
@@ -6905,9 +7003,11 @@
                     <a:lstStyle/>
                     <a:p>
                       <a:pPr>
-                        <a:buNone/>
+                        <a:defRPr sz="1000"/>
                       </a:pPr>
-                      <a:endParaRPr lang="en-SG"/>
+                      <a:r>
+                        <a:t>Xiang Ying (xiangyingg)</a:t>
+                      </a:r>
                     </a:p>
                   </a:txBody>
                   <a:tcPr anchor="ctr"/>
@@ -6918,9 +7018,11 @@
                     <a:lstStyle/>
                     <a:p>
                       <a:pPr>
-                        <a:buNone/>
+                        <a:defRPr sz="1000"/>
                       </a:pPr>
-                      <a:endParaRPr lang="en-SG"/>
+                      <a:r>
+                        <a:t>Event Planning, Change Request Lifecycle, Registrations</a:t>
+                      </a:r>
                     </a:p>
                   </a:txBody>
                   <a:tcPr anchor="ctr"/>
@@ -6931,9 +7033,11 @@
                     <a:lstStyle/>
                     <a:p>
                       <a:pPr>
-                        <a:buNone/>
+                        <a:defRPr sz="1000"/>
                       </a:pPr>
-                      <a:endParaRPr lang="en-SG"/>
+                      <a:r>
+                        <a:t>20%</a:t>
+                      </a:r>
                     </a:p>
                   </a:txBody>
                   <a:tcPr anchor="ctr"/>
@@ -6944,9 +7048,11 @@
                     <a:lstStyle/>
                     <a:p>
                       <a:pPr>
-                        <a:buNone/>
+                        <a:defRPr sz="1000"/>
                       </a:pPr>
-                      <a:endParaRPr lang="en-SG"/>
+                      <a:r>
+                        <a:t>PR #202, #203, #205, #366, #368</a:t>
+                      </a:r>
                     </a:p>
                   </a:txBody>
                   <a:tcPr anchor="ctr"/>
@@ -6957,9 +7063,11 @@
                     <a:lstStyle/>
                     <a:p>
                       <a:pPr>
-                        <a:buNone/>
+                        <a:defRPr sz="1000"/>
                       </a:pPr>
-                      <a:endParaRPr lang="en-SG"/>
+                      <a:r>
+                        <a:t>Manual test preconditions, SQL scripts, acceptance criteria</a:t>
+                      </a:r>
                     </a:p>
                   </a:txBody>
                   <a:tcPr anchor="ctr"/>
@@ -7146,19 +7254,22 @@
           </a:bodyPr>
           <a:lstStyle/>
           <a:p>
-            <a:r>
-              <a:rPr lang="en-US" i="1"/>
-              <a:t>Type answer here…</a:t>
-            </a:r>
-          </a:p>
-          <a:p>
-            <a:endParaRPr lang="en-US"/>
-          </a:p>
-          <a:p>
-            <a:endParaRPr lang="en-US"/>
-          </a:p>
-          <a:p>
-            <a:endParaRPr lang="en-US"/>
+            <a:pPr>
+              <a:defRPr sz="1200"/>
+            </a:pPr>
+            <a:r>
+              <a:t>• Public Interactive PostPlan Dashboard: Live Sprint 1–4 burndown, velocity and scope tracking is published at https://5p9t29p9jotq.postplan.dev (Draft ID: 5p9t29p9jotq), verified by check_postplan_html.py.</a:t>
+            </a:r>
+          </a:p>
+          <a:p>
+            <a:r>
+              <a:t>• Zero Technical Debt Policy: Strict Definition of Done (T-65/T-93) ensured that Done stories are never reopened, 100% unit test coverage is maintained across all changed code, and all 737 test runs are documented with audit trails.</a:t>
+            </a:r>
+          </a:p>
+          <a:p>
+            <a:r>
+              <a:t>• Sustainable Velocity: Delivered 24 pts (S1), 40 pts (S2), 34 pts (S3), and 50 pts (S4 to date) of clean, robust product functionality without skipping review or compromising main branch stability.</a:t>
+            </a:r>
           </a:p>
         </p:txBody>
       </p:sp>
@@ -7489,6 +7600,9 @@
                     <a:bodyPr/>
                     <a:lstStyle/>
                     <a:p>
+                      <a:pPr>
+                        <a:defRPr sz="1100"/>
+                      </a:pPr>
                       <a:r>
                         <a:rPr lang="en-US"/>
                         <a:t>Item</a:t>
@@ -7502,6 +7616,9 @@
                     <a:bodyPr/>
                     <a:lstStyle/>
                     <a:p>
+                      <a:pPr>
+                        <a:defRPr sz="1100"/>
+                      </a:pPr>
                       <a:r>
                         <a:rPr lang="en-US"/>
                         <a:t>URL, location or file/folder name in zip file</a:t>
@@ -7522,6 +7639,9 @@
                     <a:bodyPr/>
                     <a:lstStyle/>
                     <a:p>
+                      <a:pPr>
+                        <a:defRPr sz="1100"/>
+                      </a:pPr>
                       <a:r>
                         <a:rPr lang="en-US"/>
                         <a:t>Product backlog</a:t>
@@ -7535,7 +7655,12 @@
                     <a:bodyPr/>
                     <a:lstStyle/>
                     <a:p>
-                      <a:endParaRPr lang="en-US"/>
+                      <a:pPr>
+                        <a:defRPr sz="1100"/>
+                      </a:pPr>
+                      <a:r>
+                        <a:t>docs/CONNECTSPHERE BACKLOGS CAA 27102026.xlsx and docs/backlog/</a:t>
+                      </a:r>
                     </a:p>
                   </a:txBody>
                   <a:tcPr/>
@@ -7552,6 +7677,9 @@
                     <a:bodyPr/>
                     <a:lstStyle/>
                     <a:p>
+                      <a:pPr>
+                        <a:defRPr sz="1100"/>
+                      </a:pPr>
                       <a:r>
                         <a:rPr lang="en-US"/>
                         <a:t>Git URL (e.g. GitHub)</a:t>
@@ -7572,7 +7700,12 @@
                     <a:bodyPr/>
                     <a:lstStyle/>
                     <a:p>
-                      <a:endParaRPr lang="en-US"/>
+                      <a:pPr>
+                        <a:defRPr sz="1100"/>
+                      </a:pPr>
+                      <a:r>
+                        <a:t>https://github.com/hongyime/sgConnectSphere2026</a:t>
+                      </a:r>
                     </a:p>
                   </a:txBody>
                   <a:tcPr/>
@@ -7589,6 +7722,9 @@
                     <a:bodyPr/>
                     <a:lstStyle/>
                     <a:p>
+                      <a:pPr>
+                        <a:defRPr sz="1100"/>
+                      </a:pPr>
                       <a:r>
                         <a:rPr lang="en-US"/>
                         <a:t>Exports of project management tools (e.g. Google Sheets, Jira, Notion docs, …)</a:t>
@@ -7602,7 +7738,12 @@
                     <a:bodyPr/>
                     <a:lstStyle/>
                     <a:p>
-                      <a:endParaRPr lang="en-US"/>
+                      <a:pPr>
+                        <a:defRPr sz="1100"/>
+                      </a:pPr>
+                      <a:r>
+                        <a:t>docs/CONNECTSPHERE BACKLOGS CAA 27102026.xlsx, docs/testing/PROJECT TEST CASES CAA 27102026.xlsx, Jira Board 1</a:t>
+                      </a:r>
                     </a:p>
                   </a:txBody>
                   <a:tcPr/>
@@ -7634,7 +7775,7 @@
                         <a:buFontTx/>
                         <a:buNone/>
                         <a:tabLst/>
-                        <a:defRPr/>
+                        <a:defRPr sz="1100"/>
                       </a:pPr>
                       <a:r>
                         <a:rPr lang="en-US"/>
@@ -7649,7 +7790,12 @@
                     <a:bodyPr/>
                     <a:lstStyle/>
                     <a:p>
-                      <a:endParaRPr lang="en-US"/>
+                      <a:pPr>
+                        <a:defRPr sz="1100"/>
+                      </a:pPr>
+                      <a:r>
+                        <a:t>Sprint 4 Ceremonies: Standup, Review, Retrospective (recorded in team drive / repo docs/testing/)</a:t>
+                      </a:r>
                     </a:p>
                   </a:txBody>
                   <a:tcPr/>
@@ -7666,7 +7812,12 @@
                     <a:bodyPr/>
                     <a:lstStyle/>
                     <a:p>
-                      <a:endParaRPr lang="en-US"/>
+                      <a:pPr>
+                        <a:defRPr sz="1100"/>
+                      </a:pPr>
+                      <a:r>
+                        <a:t>Interactive Metrics Dashboard (PostPlan)</a:t>
+                      </a:r>
                     </a:p>
                   </a:txBody>
                   <a:tcPr/>
@@ -7676,7 +7827,12 @@
                     <a:bodyPr/>
                     <a:lstStyle/>
                     <a:p>
-                      <a:endParaRPr lang="en-US"/>
+                      <a:pPr>
+                        <a:defRPr sz="1100"/>
+                      </a:pPr>
+                      <a:r>
+                        <a:t>https://5p9t29p9jotq.postplan.dev (Draft ID: 5p9t29p9jotq)</a:t>
+                      </a:r>
                     </a:p>
                   </a:txBody>
                   <a:tcPr/>
@@ -7693,7 +7849,12 @@
                     <a:bodyPr/>
                     <a:lstStyle/>
                     <a:p>
-                      <a:endParaRPr lang="en-US"/>
+                      <a:pPr>
+                        <a:defRPr sz="1100"/>
+                      </a:pPr>
+                      <a:r>
+                        <a:t>Architecture &amp; C4 Models</a:t>
+                      </a:r>
                     </a:p>
                   </a:txBody>
                   <a:tcPr/>
@@ -7703,7 +7864,12 @@
                     <a:bodyPr/>
                     <a:lstStyle/>
                     <a:p>
-                      <a:endParaRPr lang="en-US"/>
+                      <a:pPr>
+                        <a:defRPr sz="1100"/>
+                      </a:pPr>
+                      <a:r>
+                        <a:t>docs/architecture/ (C4 Container &amp; Component Mermaid DSL)</a:t>
+                      </a:r>
                     </a:p>
                   </a:txBody>
                   <a:tcPr/>
@@ -7720,7 +7886,12 @@
                     <a:bodyPr/>
                     <a:lstStyle/>
                     <a:p>
-                      <a:endParaRPr lang="en-US"/>
+                      <a:pPr>
+                        <a:defRPr sz="1100"/>
+                      </a:pPr>
+                      <a:r>
+                        <a:t>Audit Trails &amp; Test Runs</a:t>
+                      </a:r>
                     </a:p>
                   </a:txBody>
                   <a:tcPr/>
@@ -7730,7 +7901,12 @@
                     <a:bodyPr/>
                     <a:lstStyle/>
                     <a:p>
-                      <a:endParaRPr lang="en-US"/>
+                      <a:pPr>
+                        <a:defRPr sz="1100"/>
+                      </a:pPr>
+                      <a:r>
+                        <a:t>docs/testing/runs/ (737 records) &amp; docs/testing/runs/evidence/ (screenshots)</a:t>
+                      </a:r>
                     </a:p>
                   </a:txBody>
                   <a:tcPr/>
@@ -7747,7 +7923,12 @@
                     <a:bodyPr/>
                     <a:lstStyle/>
                     <a:p>
-                      <a:endParaRPr lang="en-US"/>
+                      <a:pPr>
+                        <a:defRPr sz="1100"/>
+                      </a:pPr>
+                      <a:r>
+                        <a:t>Decisions &amp; SOT</a:t>
+                      </a:r>
                     </a:p>
                   </a:txBody>
                   <a:tcPr/>
@@ -7757,7 +7938,12 @@
                     <a:bodyPr/>
                     <a:lstStyle/>
                     <a:p>
-                      <a:endParaRPr lang="en-US"/>
+                      <a:pPr>
+                        <a:defRPr sz="1100"/>
+                      </a:pPr>
+                      <a:r>
+                        <a:t>docs/bdr/B-team-decisions.md &amp; docs/source-of-truth.md</a:t>
+                      </a:r>
                     </a:p>
                   </a:txBody>
                   <a:tcPr/>
@@ -8167,13 +8353,17 @@
           </a:bodyPr>
           <a:lstStyle/>
           <a:p>
-            <a:r>
-              <a:rPr lang="en-US" i="1"/>
-              <a:t>Type answer here…</a:t>
-            </a:r>
-          </a:p>
-          <a:p>
-            <a:endParaRPr lang="en-US"/>
+            <a:pPr>
+              <a:defRPr sz="1300"/>
+            </a:pPr>
+            <a:r>
+              <a:t>Cancellation Policy Cascade &amp; Attendee Refund vs Waitlist Priority:</a:t>
+            </a:r>
+          </a:p>
+          <a:p>
+            <a:r>
+              <a:t>Introducing post-confirmation cancellation rules and attendee capacity waiting lists fundamentally altered the transactional state machine. When an event or venue booking is cancelled, downstream cascades occur: attendees must be notified, reserved capacities released, waitlisted attendees auto-promoted in FIFO order with a claim window, and booking status transitions safely rolled back without data corruption. This required atomic database transactions, status polymorphism (T-59/T-63), and comprehensive regression testing.</a:t>
+            </a:r>
           </a:p>
         </p:txBody>
       </p:sp>
@@ -8249,49 +8439,22 @@
           </a:bodyPr>
           <a:lstStyle/>
           <a:p>
-            <a:r>
-              <a:rPr lang="en-US" i="1"/>
-              <a:t>Type answer here…</a:t>
-            </a:r>
-          </a:p>
-          <a:p>
-            <a:endParaRPr lang="en-US"/>
-          </a:p>
-          <a:p>
-            <a:endParaRPr lang="en-US"/>
-          </a:p>
-          <a:p>
-            <a:endParaRPr lang="en-US"/>
-          </a:p>
-          <a:p>
-            <a:endParaRPr lang="en-US"/>
-          </a:p>
-          <a:p>
-            <a:endParaRPr lang="en-US"/>
-          </a:p>
-          <a:p>
-            <a:endParaRPr lang="en-US"/>
-          </a:p>
-          <a:p>
-            <a:endParaRPr lang="en-US"/>
-          </a:p>
-          <a:p>
-            <a:endParaRPr lang="en-US"/>
-          </a:p>
-          <a:p>
-            <a:endParaRPr lang="en-US"/>
-          </a:p>
-          <a:p>
-            <a:endParaRPr lang="en-US"/>
-          </a:p>
-          <a:p>
-            <a:endParaRPr lang="en-US"/>
-          </a:p>
-          <a:p>
-            <a:endParaRPr lang="en-US"/>
-          </a:p>
-          <a:p>
-            <a:endParaRPr lang="en-US"/>
+            <a:pPr>
+              <a:defRPr sz="1300"/>
+            </a:pPr>
+            <a:r>
+              <a:t>• Architecture &amp; Database: Added migration 0025 with transactional guards for venue unavailability and cancellation cascades (backend/src/modules/venueBooking/, backend/src/modules/attendeeRegistration/).</a:t>
+            </a:r>
+          </a:p>
+          <a:p>
+            <a:r>
+              <a:t>• Frontend: Built reactive coordinator cancellation reason modals, attendee waiting list status tracking, and booking replacement workflows (frontend/src/features/events/, frontend/src/features/venues/).</a:t>
+            </a:r>
+          </a:p>
+          <a:p>
+            <a:r>
+              <a:t>• Testing &amp; Verification: Created automated unit/integration suites (e.g. attendeeCapacity.test.ts, cancellationRollback.integration.test.ts) and manual click-through scripts with SQL preconditions.</a:t>
+            </a:r>
           </a:p>
         </p:txBody>
       </p:sp>
@@ -8475,13 +8638,17 @@
           </a:bodyPr>
           <a:lstStyle/>
           <a:p>
-            <a:r>
-              <a:rPr lang="en-US" i="1"/>
-              <a:t>Type answer here…</a:t>
-            </a:r>
-          </a:p>
-          <a:p>
-            <a:endParaRPr lang="en-US"/>
+            <a:pPr>
+              <a:defRPr sz="1300"/>
+            </a:pPr>
+            <a:r>
+              <a:t>Venue Amenity Tagging &amp; Setup/Turnaround Buffer Visibility:</a:t>
+            </a:r>
+          </a:p>
+          <a:p>
+            <a:r>
+              <a:t>Displaying turnaround buffers and filtering venues by amenity tags had minimal structural impact. The underlying venue entity already tracked dimensions, layout capacities, and basic metadata. Buffers and tags operated as purely additive non-breaking attributes that did not disrupt existing booking state transitions or require state machine refactoring.</a:t>
+            </a:r>
           </a:p>
         </p:txBody>
       </p:sp>
@@ -8557,49 +8724,22 @@
           </a:bodyPr>
           <a:lstStyle/>
           <a:p>
-            <a:r>
-              <a:rPr lang="en-US" i="1"/>
-              <a:t>Type answer here…</a:t>
-            </a:r>
-          </a:p>
-          <a:p>
-            <a:endParaRPr lang="en-US"/>
-          </a:p>
-          <a:p>
-            <a:endParaRPr lang="en-US"/>
-          </a:p>
-          <a:p>
-            <a:endParaRPr lang="en-US"/>
-          </a:p>
-          <a:p>
-            <a:endParaRPr lang="en-US"/>
-          </a:p>
-          <a:p>
-            <a:endParaRPr lang="en-US"/>
-          </a:p>
-          <a:p>
-            <a:endParaRPr lang="en-US"/>
-          </a:p>
-          <a:p>
-            <a:endParaRPr lang="en-US"/>
-          </a:p>
-          <a:p>
-            <a:endParaRPr lang="en-US"/>
-          </a:p>
-          <a:p>
-            <a:endParaRPr lang="en-US"/>
-          </a:p>
-          <a:p>
-            <a:endParaRPr lang="en-US"/>
-          </a:p>
-          <a:p>
-            <a:endParaRPr lang="en-US"/>
-          </a:p>
-          <a:p>
-            <a:endParaRPr lang="en-US"/>
-          </a:p>
-          <a:p>
-            <a:endParaRPr lang="en-US"/>
+            <a:pPr>
+              <a:defRPr sz="1300"/>
+            </a:pPr>
+            <a:r>
+              <a:t>• Backend: Extended venue queries to include optional amenity tag array filtering and turnaround buffer intervals (backend/src/modules/venues/).</a:t>
+            </a:r>
+          </a:p>
+          <a:p>
+            <a:r>
+              <a:t>• Frontend: Added multi-select amenity pill filters and buffer visualization to VenueBookingForm.tsx and VenueSearch.tsx.</a:t>
+            </a:r>
+          </a:p>
+          <a:p>
+            <a:r>
+              <a:t>• Verification: Verified with component unit tests in Vitest and existing venue search integration tests; zero regression on core booking logic.</a:t>
+            </a:r>
           </a:p>
         </p:txBody>
       </p:sp>
@@ -8818,6 +8958,7 @@
                     <a:p>
                       <a:pPr>
                         <a:buNone/>
+                        <a:defRPr sz="1000"/>
                       </a:pPr>
                       <a:r>
                         <a:rPr lang="en-SG" b="1"/>
@@ -8834,6 +8975,7 @@
                     <a:p>
                       <a:pPr>
                         <a:buNone/>
+                        <a:defRPr sz="1000"/>
                       </a:pPr>
                       <a:r>
                         <a:rPr lang="en-SG" b="1"/>
@@ -8850,6 +8992,7 @@
                     <a:p>
                       <a:pPr>
                         <a:buNone/>
+                        <a:defRPr sz="1000"/>
                       </a:pPr>
                       <a:r>
                         <a:rPr lang="en-SG" b="1"/>
@@ -8866,6 +9009,7 @@
                     <a:p>
                       <a:pPr>
                         <a:buNone/>
+                        <a:defRPr sz="1000"/>
                       </a:pPr>
                       <a:r>
                         <a:rPr lang="en-SG" b="1"/>
@@ -8882,6 +9026,7 @@
                     <a:p>
                       <a:pPr>
                         <a:buNone/>
+                        <a:defRPr sz="1000"/>
                       </a:pPr>
                       <a:r>
                         <a:rPr lang="en-SG" b="1"/>
@@ -8904,11 +9049,10 @@
                     <a:lstStyle/>
                     <a:p>
                       <a:pPr>
-                        <a:buNone/>
+                        <a:defRPr sz="1000"/>
                       </a:pPr>
                       <a:r>
-                        <a:rPr lang="en-SG"/>
-                        <a:t>1</a:t>
+                        <a:t>1 (T-59 Database Isolation)</a:t>
                       </a:r>
                     </a:p>
                   </a:txBody>
@@ -8920,9 +9064,11 @@
                     <a:lstStyle/>
                     <a:p>
                       <a:pPr>
-                        <a:buNone/>
+                        <a:defRPr sz="1000"/>
                       </a:pPr>
-                      <a:endParaRPr lang="en-SG"/>
+                      <a:r>
+                        <a:t>Generated naive db:reset scripts that wiped shared Supabase DB schemas during teardown.</a:t>
+                      </a:r>
                     </a:p>
                   </a:txBody>
                   <a:tcPr anchor="ctr"/>
@@ -8933,9 +9079,11 @@
                     <a:lstStyle/>
                     <a:p>
                       <a:pPr>
-                        <a:buNone/>
+                        <a:defRPr sz="1000"/>
                       </a:pPr>
-                      <a:endParaRPr lang="en-SG"/>
+                      <a:r>
+                        <a:t>Architected T-59: an isolated Supabase test schema using rollback-based transactional saves guarded by CI gates.</a:t>
+                      </a:r>
                     </a:p>
                   </a:txBody>
                   <a:tcPr anchor="ctr"/>
@@ -8946,9 +9094,11 @@
                     <a:lstStyle/>
                     <a:p>
                       <a:pPr>
-                        <a:buNone/>
+                        <a:defRPr sz="1000"/>
                       </a:pPr>
-                      <a:endParaRPr lang="en-SG"/>
+                      <a:r>
+                        <a:t>Prevented catastrophic wiping of shared staging/test data and protected cloud credentials.</a:t>
+                      </a:r>
                     </a:p>
                   </a:txBody>
                   <a:tcPr anchor="ctr"/>
@@ -8959,9 +9109,11 @@
                     <a:lstStyle/>
                     <a:p>
                       <a:pPr>
-                        <a:buNone/>
+                        <a:defRPr sz="1000"/>
                       </a:pPr>
-                      <a:endParaRPr lang="en-SG"/>
+                      <a:r>
+                        <a:t>docs/bdr/B-team-decisions.md (T-59), scripts/check.py, docs/testing/supabase-test-schema.md</a:t>
+                      </a:r>
                     </a:p>
                   </a:txBody>
                   <a:tcPr anchor="ctr"/>
@@ -8979,11 +9131,10 @@
                     <a:lstStyle/>
                     <a:p>
                       <a:pPr>
-                        <a:buNone/>
+                        <a:defRPr sz="1000"/>
                       </a:pPr>
                       <a:r>
-                        <a:rPr lang="en-SG"/>
-                        <a:t>2</a:t>
+                        <a:t>2 (T-65 / T-93 Manual Test Verification)</a:t>
                       </a:r>
                     </a:p>
                   </a:txBody>
@@ -8995,9 +9146,11 @@
                     <a:lstStyle/>
                     <a:p>
                       <a:pPr>
-                        <a:buNone/>
+                        <a:defRPr sz="1000"/>
                       </a:pPr>
-                      <a:endParaRPr lang="en-SG"/>
+                      <a:r>
+                        <a:t>Wrote synthetic mocks hallucinating 100% pass rates by mocking away genuine DOM and network failures.</a:t>
+                      </a:r>
                     </a:p>
                   </a:txBody>
                   <a:tcPr anchor="ctr"/>
@@ -9008,9 +9161,11 @@
                     <a:lstStyle/>
                     <a:p>
                       <a:pPr>
-                        <a:buNone/>
+                        <a:defRPr sz="1000"/>
                       </a:pPr>
-                      <a:endParaRPr lang="en-SG"/>
+                      <a:r>
+                        <a:t>Enforced T-65 and T-93: mandatory execution of real E2E tests with hand-taken human screenshots stored in the repo.</a:t>
+                      </a:r>
                     </a:p>
                   </a:txBody>
                   <a:tcPr anchor="ctr"/>
@@ -9021,9 +9176,11 @@
                     <a:lstStyle/>
                     <a:p>
                       <a:pPr>
-                        <a:buNone/>
+                        <a:defRPr sz="1000"/>
                       </a:pPr>
-                      <a:endParaRPr lang="en-SG"/>
+                      <a:r>
+                        <a:t>Caught real browser rendering issues, focus management bugs, and layout overflows that mocks missed.</a:t>
+                      </a:r>
                     </a:p>
                   </a:txBody>
                   <a:tcPr anchor="ctr"/>
@@ -9034,9 +9191,11 @@
                     <a:lstStyle/>
                     <a:p>
                       <a:pPr>
-                        <a:buNone/>
+                        <a:defRPr sz="1000"/>
                       </a:pPr>
-                      <a:endParaRPr lang="en-SG"/>
+                      <a:r>
+                        <a:t>737 run records in docs/testing/runs/, evidence/ directories with PNGs (e.g. PR #368, PR #373)</a:t>
+                      </a:r>
                     </a:p>
                   </a:txBody>
                   <a:tcPr anchor="ctr"/>
@@ -9054,11 +9213,10 @@
                     <a:lstStyle/>
                     <a:p>
                       <a:pPr>
-                        <a:buNone/>
+                        <a:defRPr sz="1000"/>
                       </a:pPr>
                       <a:r>
-                        <a:rPr lang="en-SG"/>
-                        <a:t>3</a:t>
+                        <a:t>3 (Booking Concurrency &amp; Polymorphism)</a:t>
                       </a:r>
                     </a:p>
                   </a:txBody>
@@ -9070,9 +9228,11 @@
                     <a:lstStyle/>
                     <a:p>
                       <a:pPr>
-                        <a:buNone/>
+                        <a:defRPr sz="1000"/>
                       </a:pPr>
-                      <a:endParaRPr lang="en-SG"/>
+                      <a:r>
+                        <a:t>Generated simple CRUD routes that accepted concurrent requests, creating double-booking race conditions.</a:t>
+                      </a:r>
                     </a:p>
                   </a:txBody>
                   <a:tcPr anchor="ctr"/>
@@ -9083,9 +9243,11 @@
                     <a:lstStyle/>
                     <a:p>
                       <a:pPr>
-                        <a:buNone/>
+                        <a:defRPr sz="1000"/>
                       </a:pPr>
-                      <a:endParaRPr lang="en-SG"/>
+                      <a:r>
+                        <a:t>Designed Booking Status Polymorphism and Rule B First Accepted Claim logic with PostgreSQL row-level locks.</a:t>
+                      </a:r>
                     </a:p>
                   </a:txBody>
                   <a:tcPr anchor="ctr"/>
@@ -9096,9 +9258,11 @@
                     <a:lstStyle/>
                     <a:p>
                       <a:pPr>
-                        <a:buNone/>
+                        <a:defRPr sz="1000"/>
                       </a:pPr>
-                      <a:endParaRPr lang="en-SG"/>
+                      <a:r>
+                        <a:t>Guaranteed absolute transactional integrity, preventing double-bookings across concurrent organisers.</a:t>
+                      </a:r>
                     </a:p>
                   </a:txBody>
                   <a:tcPr anchor="ctr"/>
@@ -9109,9 +9273,11 @@
                     <a:lstStyle/>
                     <a:p>
                       <a:pPr>
-                        <a:buNone/>
+                        <a:defRPr sz="1000"/>
                       </a:pPr>
-                      <a:endParaRPr lang="en-SG"/>
+                      <a:r>
+                        <a:t>PR #339, PR #371, docs/bdr/B-team-decisions.md (T-63/T-68), backend/src/modules/venueBooking/</a:t>
+                      </a:r>
                     </a:p>
                   </a:txBody>
                   <a:tcPr anchor="ctr"/>
@@ -9298,16 +9464,27 @@
           </a:bodyPr>
           <a:lstStyle/>
           <a:p>
-            <a:r>
-              <a:rPr lang="en-US" i="1"/>
-              <a:t>Type answer here…</a:t>
-            </a:r>
-          </a:p>
-          <a:p>
-            <a:endParaRPr lang="en-US"/>
-          </a:p>
-          <a:p>
-            <a:endParaRPr lang="en-US"/>
+            <a:pPr>
+              <a:defRPr sz="1100"/>
+            </a:pPr>
+            <a:r>
+              <a:t>Yes. Three key incidents of AI-induced rework occurred:</a:t>
+            </a:r>
+          </a:p>
+          <a:p>
+            <a:r>
+              <a:t>1. Destructive Database Scripts: AI initially attempted to add db:reset calls to test fixtures, which would have wiped our team's shared Supabase database. The team halted execution and codified T-59 guardrails.</a:t>
+            </a:r>
+          </a:p>
+          <a:p>
+            <a:r>
+              <a:t>2. Flaky Async DOM Assertions: In RefusedEdit.navigation.test.tsx, AI generated synchronous expect(...).toHaveFocus() assertions that passed intermittently on fast machines but flaked in CI (#372). We refactored to web-first waitFor polling on the container element (#373).</a:t>
+            </a:r>
+          </a:p>
+          <a:p>
+            <a:r>
+              <a:t>3. Over-Mocking: AI mocked backend services so heavily in frontend tests that contract breakages slipped through unnoticed until manual click-through testing.</a:t>
+            </a:r>
           </a:p>
         </p:txBody>
       </p:sp>
@@ -9383,16 +9560,12 @@
           </a:bodyPr>
           <a:lstStyle/>
           <a:p>
-            <a:r>
-              <a:rPr lang="en-US" i="1"/>
-              <a:t>Type answer here…</a:t>
-            </a:r>
-          </a:p>
-          <a:p>
-            <a:endParaRPr lang="en-US"/>
-          </a:p>
-          <a:p>
-            <a:endParaRPr lang="en-US"/>
+            <a:pPr>
+              <a:defRPr sz="1100"/>
+            </a:pPr>
+            <a:r>
+              <a:t>The Venue Booking Concurrency &amp; Status Polymorphism Architecture (refactor/booking-status-polymorphism, PR #371, and E06-S06 Rule B). AI models consistently propose naive status strings without handling edge cases like concurrent approval race conditions, partial slot releases, or automatic withdrawal of conflicting holds. Our team architected the formal state machine, transaction isolation levels, and comprehensive rollback handling.</a:t>
+            </a:r>
           </a:p>
         </p:txBody>
       </p:sp>
@@ -9468,16 +9641,12 @@
           </a:bodyPr>
           <a:lstStyle/>
           <a:p>
-            <a:r>
-              <a:rPr lang="en-US" i="1"/>
-              <a:t>Type answer here…</a:t>
-            </a:r>
-          </a:p>
-          <a:p>
-            <a:endParaRPr lang="en-US"/>
-          </a:p>
-          <a:p>
-            <a:endParaRPr lang="en-US"/>
+            <a:pPr>
+              <a:defRPr sz="1100"/>
+            </a:pPr>
+            <a:r>
+              <a:t>Team Decision T-63 (Near-Match Venue Scoring) and Rule B Booking Claim Policy. When an organiser's requested capacity or equipment cannot be perfectly matched, human judgement was required to determine whether to reject outright or suggest suitable near-matches with clear warnings, balancing user experience against operational risk.</a:t>
+            </a:r>
           </a:p>
         </p:txBody>
       </p:sp>
@@ -9510,13 +9679,11 @@
           <a:lstStyle/>
           <a:p>
             <a:pPr>
-              <a:buNone/>
+              <a:defRPr sz="1300" b="1"/>
             </a:pPr>
             <a:r>
-              <a:rPr lang="en-SG" b="1"/>
-              <a:t>“The most important value our team added beyond AI was __________ because __________.”</a:t>
-            </a:r>
-            <a:endParaRPr lang="en-SG"/>
+              <a:t>“The most important value our team added beyond AI was architectural discipline and empirical verification because AI can generate plausible code but cannot guarantee semantic correctness, system safety, or truthful verification evidence.”</a:t>
+            </a:r>
           </a:p>
         </p:txBody>
       </p:sp>
@@ -9805,15 +9972,12 @@
           </a:bodyPr>
           <a:lstStyle/>
           <a:p>
-            <a:r>
-              <a:rPr lang="en-US" i="1"/>
-              <a:t>Type answer here…</a:t>
-            </a:r>
-          </a:p>
-          <a:p>
-            <a:endParaRPr lang="en-US">
-              <a:cs typeface="Arial"/>
-            </a:endParaRPr>
+            <a:pPr>
+              <a:defRPr sz="1200"/>
+            </a:pPr>
+            <a:r>
+              <a:t>Delegated boilerplate scaffolding, repetitive CRUD endpoint generation, initial test fixture typing, and translation of user stories into preliminary test matrices.</a:t>
+            </a:r>
           </a:p>
         </p:txBody>
       </p:sp>
@@ -9850,15 +10014,12 @@
           </a:bodyPr>
           <a:lstStyle/>
           <a:p>
-            <a:r>
-              <a:rPr lang="en-US" i="1"/>
-              <a:t>Type answer here…</a:t>
-            </a:r>
-          </a:p>
-          <a:p>
-            <a:endParaRPr lang="en-US">
-              <a:cs typeface="Arial"/>
-            </a:endParaRPr>
+            <a:pPr>
+              <a:defRPr sz="1200"/>
+            </a:pPr>
+            <a:r>
+              <a:t>Constrained AI via repository guardrails: AGENTS.md instructions, pre-commit hooks (detect-secrets, check.py), max 2 open PR limit, four-section PR body templates, and strict forbidden actions (no db:reset, no modifying STATE.md).</a:t>
+            </a:r>
           </a:p>
         </p:txBody>
       </p:sp>
@@ -9895,15 +10056,12 @@
           </a:bodyPr>
           <a:lstStyle/>
           <a:p>
-            <a:r>
-              <a:rPr lang="en-US" i="1"/>
-              <a:t>Type answer here…</a:t>
-            </a:r>
-          </a:p>
-          <a:p>
-            <a:endParaRPr lang="en-US">
-              <a:cs typeface="Arial"/>
-            </a:endParaRPr>
+            <a:pPr>
+              <a:defRPr sz="1200"/>
+            </a:pPr>
+            <a:r>
+              <a:t>Verified every change through a 15-check CI matrix (application-checks, Playwright E2E, Vitest, 100% unit test coverage requirement), followed by human peer review and T-65 manual click-through execution.</a:t>
+            </a:r>
           </a:p>
         </p:txBody>
       </p:sp>
@@ -9940,15 +10098,12 @@
           </a:bodyPr>
           <a:lstStyle/>
           <a:p>
-            <a:r>
-              <a:rPr lang="en-US" i="1"/>
-              <a:t>Type answer here…</a:t>
-            </a:r>
-          </a:p>
-          <a:p>
-            <a:endParaRPr lang="en-US">
-              <a:cs typeface="Arial"/>
-            </a:endParaRPr>
+            <a:pPr>
+              <a:defRPr sz="1200"/>
+            </a:pPr>
+            <a:r>
+              <a:t>Owned complete responsibility for code quality, architectural decisions, Jira reconciliation, and final system stability. Rejected AI hallucinations immediately and took full accountability during Sprint Reviews.</a:t>
+            </a:r>
           </a:p>
         </p:txBody>
       </p:sp>
@@ -10130,43 +10285,27 @@
           </a:bodyPr>
           <a:lstStyle/>
           <a:p>
-            <a:r>
-              <a:rPr lang="en-US" i="1"/>
-              <a:t>Type answer here…</a:t>
-            </a:r>
-          </a:p>
-          <a:p>
-            <a:endParaRPr lang="en-US"/>
-          </a:p>
-          <a:p>
-            <a:endParaRPr lang="en-US"/>
-          </a:p>
-          <a:p>
-            <a:endParaRPr lang="en-US"/>
-          </a:p>
-          <a:p>
-            <a:endParaRPr lang="en-US"/>
-          </a:p>
-          <a:p>
-            <a:endParaRPr lang="en-US"/>
-          </a:p>
-          <a:p>
-            <a:endParaRPr lang="en-US"/>
-          </a:p>
-          <a:p>
-            <a:endParaRPr lang="en-US"/>
-          </a:p>
-          <a:p>
-            <a:endParaRPr lang="en-US"/>
-          </a:p>
-          <a:p>
-            <a:endParaRPr lang="en-US"/>
-          </a:p>
-          <a:p>
-            <a:endParaRPr lang="en-US"/>
-          </a:p>
-          <a:p>
-            <a:endParaRPr lang="en-US"/>
+            <a:pPr>
+              <a:defRPr sz="1300"/>
+            </a:pPr>
+            <a:r>
+              <a:t>• Trunk-Based Collaboration with Short-Lived Branches: Enforced strict branch prefixes (feat/, fix/, docs/, test/, chore/) tied directly to Jira keys (e.g. feature/SCRUM-216-e09-registration-list).</a:t>
+            </a:r>
+          </a:p>
+          <a:p>
+            <a:r>
+              <a:t>• Guardrails &amp; PR Hygiene: Maximum 2 open PRs per author (scripts/check_pr_guardrails.py) prevented WIP bloat and merge debt. Every PR required four mandatory headers (What and why, Verification, Checklist, Follow-ups).</a:t>
+            </a:r>
+          </a:p>
+          <a:p>
+            <a:r>
+              <a:t>• Worktree Isolation: Utilised Git worktrees (sgConnectSphere2026-wt/) to review and test stacked branches without dirtying local environments, validated by check_worktrees.py.</a:t>
+            </a:r>
+          </a:p>
+          <a:p>
+            <a:r>
+              <a:t>• Linear Git History: Rebase-and-merge / squash workflow kept main clean, bisectable, and always production-ready, backed by branch protection rules.</a:t>
+            </a:r>
           </a:p>
         </p:txBody>
       </p:sp>

</xml_diff>